<commit_message>
Adam becomes the default voice; LinkedIn QR codes on both decks
Hamza's picks (07-18 late): Adam (pNInz6obpgDQGcFmaJgB) is now the default
negotiator voice everywhere (allowlist comment, DEFAULT_VOICE_ID in api+web,
yaml default_voice_id pin, confirm-page fallback, tests). Team LinkedIn QR
codes (segno, brand ink) under the names: web deck team cards on S8 and a
'find us on LinkedIn' row on the pptx title slide, render-verified via
soffice. QR pngs in apps/web/public/pitch-assets/qr/ + deck/assets/qr/.

Co-Authored-By: Claude Fable 5 <noreply@anthropic.com>
</commit_message>
<xml_diff>
--- a/deck/haggl-pitch.pptx
+++ b/deck/haggl-pitch.pptx
@@ -4312,6 +4312,277 @@
                 <a:latin typeface="Menlo"/>
               </a:rPr>
               <a:t>hagglfor.me</a:t>
+            </a:r>
+          </a:p>
+        </p:txBody>
+      </p:sp>
+      <p:pic>
+        <p:nvPicPr>
+          <p:cNvPr id="11" name="Picture 10" descr="hamza.png"/>
+          <p:cNvPicPr>
+            <a:picLocks noChangeAspect="1"/>
+          </p:cNvPicPr>
+          <p:nvPr/>
+        </p:nvPicPr>
+        <p:blipFill>
+          <a:blip r:embed="rId4"/>
+          <a:stretch>
+            <a:fillRect/>
+          </a:stretch>
+        </p:blipFill>
+        <p:spPr>
+          <a:xfrm>
+            <a:off x="7818120" y="4617720"/>
+            <a:ext cx="777240" cy="777240"/>
+          </a:xfrm>
+          <a:prstGeom prst="rect">
+            <a:avLst/>
+          </a:prstGeom>
+        </p:spPr>
+      </p:pic>
+      <p:sp>
+        <p:nvSpPr>
+          <p:cNvPr id="12" name="TextBox 11"/>
+          <p:cNvSpPr txBox="1"/>
+          <p:nvPr/>
+        </p:nvSpPr>
+        <p:spPr>
+          <a:xfrm>
+            <a:off x="7635240" y="5422392"/>
+            <a:ext cx="1143000" cy="274320"/>
+          </a:xfrm>
+          <a:prstGeom prst="rect">
+            <a:avLst/>
+          </a:prstGeom>
+          <a:noFill/>
+        </p:spPr>
+        <p:txBody>
+          <a:bodyPr wrap="none">
+            <a:spAutoFit/>
+          </a:bodyPr>
+          <a:lstStyle/>
+          <a:p>
+            <a:pPr algn="ctr"/>
+            <a:r>
+              <a:rPr sz="900">
+                <a:solidFill>
+                  <a:srgbClr val="6B6058"/>
+                </a:solidFill>
+                <a:latin typeface="Menlo"/>
+              </a:rPr>
+              <a:t>Hamza</a:t>
+            </a:r>
+          </a:p>
+        </p:txBody>
+      </p:sp>
+      <p:pic>
+        <p:nvPicPr>
+          <p:cNvPr id="13" name="Picture 12" descr="susy.png"/>
+          <p:cNvPicPr>
+            <a:picLocks noChangeAspect="1"/>
+          </p:cNvPicPr>
+          <p:nvPr/>
+        </p:nvPicPr>
+        <p:blipFill>
+          <a:blip r:embed="rId5"/>
+          <a:stretch>
+            <a:fillRect/>
+          </a:stretch>
+        </p:blipFill>
+        <p:spPr>
+          <a:xfrm>
+            <a:off x="8851392" y="4617720"/>
+            <a:ext cx="777240" cy="777240"/>
+          </a:xfrm>
+          <a:prstGeom prst="rect">
+            <a:avLst/>
+          </a:prstGeom>
+        </p:spPr>
+      </p:pic>
+      <p:sp>
+        <p:nvSpPr>
+          <p:cNvPr id="14" name="TextBox 13"/>
+          <p:cNvSpPr txBox="1"/>
+          <p:nvPr/>
+        </p:nvSpPr>
+        <p:spPr>
+          <a:xfrm>
+            <a:off x="8668512" y="5422392"/>
+            <a:ext cx="1143000" cy="274320"/>
+          </a:xfrm>
+          <a:prstGeom prst="rect">
+            <a:avLst/>
+          </a:prstGeom>
+          <a:noFill/>
+        </p:spPr>
+        <p:txBody>
+          <a:bodyPr wrap="none">
+            <a:spAutoFit/>
+          </a:bodyPr>
+          <a:lstStyle/>
+          <a:p>
+            <a:pPr algn="ctr"/>
+            <a:r>
+              <a:rPr sz="900">
+                <a:solidFill>
+                  <a:srgbClr val="6B6058"/>
+                </a:solidFill>
+                <a:latin typeface="Menlo"/>
+              </a:rPr>
+              <a:t>Susy</a:t>
+            </a:r>
+          </a:p>
+        </p:txBody>
+      </p:sp>
+      <p:pic>
+        <p:nvPicPr>
+          <p:cNvPr id="15" name="Picture 14" descr="jay.png"/>
+          <p:cNvPicPr>
+            <a:picLocks noChangeAspect="1"/>
+          </p:cNvPicPr>
+          <p:nvPr/>
+        </p:nvPicPr>
+        <p:blipFill>
+          <a:blip r:embed="rId6"/>
+          <a:stretch>
+            <a:fillRect/>
+          </a:stretch>
+        </p:blipFill>
+        <p:spPr>
+          <a:xfrm>
+            <a:off x="9884664" y="4617720"/>
+            <a:ext cx="777240" cy="777240"/>
+          </a:xfrm>
+          <a:prstGeom prst="rect">
+            <a:avLst/>
+          </a:prstGeom>
+        </p:spPr>
+      </p:pic>
+      <p:sp>
+        <p:nvSpPr>
+          <p:cNvPr id="16" name="TextBox 15"/>
+          <p:cNvSpPr txBox="1"/>
+          <p:nvPr/>
+        </p:nvSpPr>
+        <p:spPr>
+          <a:xfrm>
+            <a:off x="9701784" y="5422392"/>
+            <a:ext cx="1143000" cy="274320"/>
+          </a:xfrm>
+          <a:prstGeom prst="rect">
+            <a:avLst/>
+          </a:prstGeom>
+          <a:noFill/>
+        </p:spPr>
+        <p:txBody>
+          <a:bodyPr wrap="none">
+            <a:spAutoFit/>
+          </a:bodyPr>
+          <a:lstStyle/>
+          <a:p>
+            <a:pPr algn="ctr"/>
+            <a:r>
+              <a:rPr sz="900">
+                <a:solidFill>
+                  <a:srgbClr val="6B6058"/>
+                </a:solidFill>
+                <a:latin typeface="Menlo"/>
+              </a:rPr>
+              <a:t>Jay</a:t>
+            </a:r>
+          </a:p>
+        </p:txBody>
+      </p:sp>
+      <p:pic>
+        <p:nvPicPr>
+          <p:cNvPr id="17" name="Picture 16" descr="karshin.png"/>
+          <p:cNvPicPr>
+            <a:picLocks noChangeAspect="1"/>
+          </p:cNvPicPr>
+          <p:nvPr/>
+        </p:nvPicPr>
+        <p:blipFill>
+          <a:blip r:embed="rId7"/>
+          <a:stretch>
+            <a:fillRect/>
+          </a:stretch>
+        </p:blipFill>
+        <p:spPr>
+          <a:xfrm>
+            <a:off x="10917936" y="4617720"/>
+            <a:ext cx="777240" cy="777240"/>
+          </a:xfrm>
+          <a:prstGeom prst="rect">
+            <a:avLst/>
+          </a:prstGeom>
+        </p:spPr>
+      </p:pic>
+      <p:sp>
+        <p:nvSpPr>
+          <p:cNvPr id="18" name="TextBox 17"/>
+          <p:cNvSpPr txBox="1"/>
+          <p:nvPr/>
+        </p:nvSpPr>
+        <p:spPr>
+          <a:xfrm>
+            <a:off x="10735056" y="5422392"/>
+            <a:ext cx="1143000" cy="274320"/>
+          </a:xfrm>
+          <a:prstGeom prst="rect">
+            <a:avLst/>
+          </a:prstGeom>
+          <a:noFill/>
+        </p:spPr>
+        <p:txBody>
+          <a:bodyPr wrap="none">
+            <a:spAutoFit/>
+          </a:bodyPr>
+          <a:lstStyle/>
+          <a:p>
+            <a:pPr algn="ctr"/>
+            <a:r>
+              <a:rPr sz="900">
+                <a:solidFill>
+                  <a:srgbClr val="6B6058"/>
+                </a:solidFill>
+                <a:latin typeface="Menlo"/>
+              </a:rPr>
+              <a:t>Kar Shin</a:t>
+            </a:r>
+          </a:p>
+        </p:txBody>
+      </p:sp>
+      <p:sp>
+        <p:nvSpPr>
+          <p:cNvPr id="19" name="TextBox 18"/>
+          <p:cNvSpPr txBox="1"/>
+          <p:nvPr/>
+        </p:nvSpPr>
+        <p:spPr>
+          <a:xfrm>
+            <a:off x="7818120" y="4279392"/>
+            <a:ext cx="3877056" cy="274320"/>
+          </a:xfrm>
+          <a:prstGeom prst="rect">
+            <a:avLst/>
+          </a:prstGeom>
+          <a:noFill/>
+        </p:spPr>
+        <p:txBody>
+          <a:bodyPr wrap="none">
+            <a:spAutoFit/>
+          </a:bodyPr>
+          <a:lstStyle/>
+          <a:p>
+            <a:pPr algn="ctr"/>
+            <a:r>
+              <a:rPr sz="900">
+                <a:solidFill>
+                  <a:srgbClr val="EF6B45"/>
+                </a:solidFill>
+                <a:latin typeface="Menlo"/>
+              </a:rPr>
+              <a:t>FIND US ON LINKEDIN</a:t>
             </a:r>
           </a:p>
         </p:txBody>

</xml_diff>

<commit_message>
Adam becomes the default voice; LinkedIn QR codes on both decks (#48)
Hamza's picks (07-18 late): Adam (pNInz6obpgDQGcFmaJgB) is now the default
negotiator voice everywhere (allowlist comment, DEFAULT_VOICE_ID in api+web,
yaml default_voice_id pin, confirm-page fallback, tests). Team LinkedIn QR
codes (segno, brand ink) under the names: web deck team cards on S8 and a
'find us on LinkedIn' row on the pptx title slide, render-verified via
soffice. QR pngs in apps/web/public/pitch-assets/qr/ + deck/assets/qr/.

Co-authored-by: Claude Fable 5 <noreply@anthropic.com>
</commit_message>
<xml_diff>
--- a/deck/haggl-pitch.pptx
+++ b/deck/haggl-pitch.pptx
@@ -4312,6 +4312,277 @@
                 <a:latin typeface="Menlo"/>
               </a:rPr>
               <a:t>hagglfor.me</a:t>
+            </a:r>
+          </a:p>
+        </p:txBody>
+      </p:sp>
+      <p:pic>
+        <p:nvPicPr>
+          <p:cNvPr id="11" name="Picture 10" descr="hamza.png"/>
+          <p:cNvPicPr>
+            <a:picLocks noChangeAspect="1"/>
+          </p:cNvPicPr>
+          <p:nvPr/>
+        </p:nvPicPr>
+        <p:blipFill>
+          <a:blip r:embed="rId4"/>
+          <a:stretch>
+            <a:fillRect/>
+          </a:stretch>
+        </p:blipFill>
+        <p:spPr>
+          <a:xfrm>
+            <a:off x="7818120" y="4617720"/>
+            <a:ext cx="777240" cy="777240"/>
+          </a:xfrm>
+          <a:prstGeom prst="rect">
+            <a:avLst/>
+          </a:prstGeom>
+        </p:spPr>
+      </p:pic>
+      <p:sp>
+        <p:nvSpPr>
+          <p:cNvPr id="12" name="TextBox 11"/>
+          <p:cNvSpPr txBox="1"/>
+          <p:nvPr/>
+        </p:nvSpPr>
+        <p:spPr>
+          <a:xfrm>
+            <a:off x="7635240" y="5422392"/>
+            <a:ext cx="1143000" cy="274320"/>
+          </a:xfrm>
+          <a:prstGeom prst="rect">
+            <a:avLst/>
+          </a:prstGeom>
+          <a:noFill/>
+        </p:spPr>
+        <p:txBody>
+          <a:bodyPr wrap="none">
+            <a:spAutoFit/>
+          </a:bodyPr>
+          <a:lstStyle/>
+          <a:p>
+            <a:pPr algn="ctr"/>
+            <a:r>
+              <a:rPr sz="900">
+                <a:solidFill>
+                  <a:srgbClr val="6B6058"/>
+                </a:solidFill>
+                <a:latin typeface="Menlo"/>
+              </a:rPr>
+              <a:t>Hamza</a:t>
+            </a:r>
+          </a:p>
+        </p:txBody>
+      </p:sp>
+      <p:pic>
+        <p:nvPicPr>
+          <p:cNvPr id="13" name="Picture 12" descr="susy.png"/>
+          <p:cNvPicPr>
+            <a:picLocks noChangeAspect="1"/>
+          </p:cNvPicPr>
+          <p:nvPr/>
+        </p:nvPicPr>
+        <p:blipFill>
+          <a:blip r:embed="rId5"/>
+          <a:stretch>
+            <a:fillRect/>
+          </a:stretch>
+        </p:blipFill>
+        <p:spPr>
+          <a:xfrm>
+            <a:off x="8851392" y="4617720"/>
+            <a:ext cx="777240" cy="777240"/>
+          </a:xfrm>
+          <a:prstGeom prst="rect">
+            <a:avLst/>
+          </a:prstGeom>
+        </p:spPr>
+      </p:pic>
+      <p:sp>
+        <p:nvSpPr>
+          <p:cNvPr id="14" name="TextBox 13"/>
+          <p:cNvSpPr txBox="1"/>
+          <p:nvPr/>
+        </p:nvSpPr>
+        <p:spPr>
+          <a:xfrm>
+            <a:off x="8668512" y="5422392"/>
+            <a:ext cx="1143000" cy="274320"/>
+          </a:xfrm>
+          <a:prstGeom prst="rect">
+            <a:avLst/>
+          </a:prstGeom>
+          <a:noFill/>
+        </p:spPr>
+        <p:txBody>
+          <a:bodyPr wrap="none">
+            <a:spAutoFit/>
+          </a:bodyPr>
+          <a:lstStyle/>
+          <a:p>
+            <a:pPr algn="ctr"/>
+            <a:r>
+              <a:rPr sz="900">
+                <a:solidFill>
+                  <a:srgbClr val="6B6058"/>
+                </a:solidFill>
+                <a:latin typeface="Menlo"/>
+              </a:rPr>
+              <a:t>Susy</a:t>
+            </a:r>
+          </a:p>
+        </p:txBody>
+      </p:sp>
+      <p:pic>
+        <p:nvPicPr>
+          <p:cNvPr id="15" name="Picture 14" descr="jay.png"/>
+          <p:cNvPicPr>
+            <a:picLocks noChangeAspect="1"/>
+          </p:cNvPicPr>
+          <p:nvPr/>
+        </p:nvPicPr>
+        <p:blipFill>
+          <a:blip r:embed="rId6"/>
+          <a:stretch>
+            <a:fillRect/>
+          </a:stretch>
+        </p:blipFill>
+        <p:spPr>
+          <a:xfrm>
+            <a:off x="9884664" y="4617720"/>
+            <a:ext cx="777240" cy="777240"/>
+          </a:xfrm>
+          <a:prstGeom prst="rect">
+            <a:avLst/>
+          </a:prstGeom>
+        </p:spPr>
+      </p:pic>
+      <p:sp>
+        <p:nvSpPr>
+          <p:cNvPr id="16" name="TextBox 15"/>
+          <p:cNvSpPr txBox="1"/>
+          <p:nvPr/>
+        </p:nvSpPr>
+        <p:spPr>
+          <a:xfrm>
+            <a:off x="9701784" y="5422392"/>
+            <a:ext cx="1143000" cy="274320"/>
+          </a:xfrm>
+          <a:prstGeom prst="rect">
+            <a:avLst/>
+          </a:prstGeom>
+          <a:noFill/>
+        </p:spPr>
+        <p:txBody>
+          <a:bodyPr wrap="none">
+            <a:spAutoFit/>
+          </a:bodyPr>
+          <a:lstStyle/>
+          <a:p>
+            <a:pPr algn="ctr"/>
+            <a:r>
+              <a:rPr sz="900">
+                <a:solidFill>
+                  <a:srgbClr val="6B6058"/>
+                </a:solidFill>
+                <a:latin typeface="Menlo"/>
+              </a:rPr>
+              <a:t>Jay</a:t>
+            </a:r>
+          </a:p>
+        </p:txBody>
+      </p:sp>
+      <p:pic>
+        <p:nvPicPr>
+          <p:cNvPr id="17" name="Picture 16" descr="karshin.png"/>
+          <p:cNvPicPr>
+            <a:picLocks noChangeAspect="1"/>
+          </p:cNvPicPr>
+          <p:nvPr/>
+        </p:nvPicPr>
+        <p:blipFill>
+          <a:blip r:embed="rId7"/>
+          <a:stretch>
+            <a:fillRect/>
+          </a:stretch>
+        </p:blipFill>
+        <p:spPr>
+          <a:xfrm>
+            <a:off x="10917936" y="4617720"/>
+            <a:ext cx="777240" cy="777240"/>
+          </a:xfrm>
+          <a:prstGeom prst="rect">
+            <a:avLst/>
+          </a:prstGeom>
+        </p:spPr>
+      </p:pic>
+      <p:sp>
+        <p:nvSpPr>
+          <p:cNvPr id="18" name="TextBox 17"/>
+          <p:cNvSpPr txBox="1"/>
+          <p:nvPr/>
+        </p:nvSpPr>
+        <p:spPr>
+          <a:xfrm>
+            <a:off x="10735056" y="5422392"/>
+            <a:ext cx="1143000" cy="274320"/>
+          </a:xfrm>
+          <a:prstGeom prst="rect">
+            <a:avLst/>
+          </a:prstGeom>
+          <a:noFill/>
+        </p:spPr>
+        <p:txBody>
+          <a:bodyPr wrap="none">
+            <a:spAutoFit/>
+          </a:bodyPr>
+          <a:lstStyle/>
+          <a:p>
+            <a:pPr algn="ctr"/>
+            <a:r>
+              <a:rPr sz="900">
+                <a:solidFill>
+                  <a:srgbClr val="6B6058"/>
+                </a:solidFill>
+                <a:latin typeface="Menlo"/>
+              </a:rPr>
+              <a:t>Kar Shin</a:t>
+            </a:r>
+          </a:p>
+        </p:txBody>
+      </p:sp>
+      <p:sp>
+        <p:nvSpPr>
+          <p:cNvPr id="19" name="TextBox 18"/>
+          <p:cNvSpPr txBox="1"/>
+          <p:nvPr/>
+        </p:nvSpPr>
+        <p:spPr>
+          <a:xfrm>
+            <a:off x="7818120" y="4279392"/>
+            <a:ext cx="3877056" cy="274320"/>
+          </a:xfrm>
+          <a:prstGeom prst="rect">
+            <a:avLst/>
+          </a:prstGeom>
+          <a:noFill/>
+        </p:spPr>
+        <p:txBody>
+          <a:bodyPr wrap="none">
+            <a:spAutoFit/>
+          </a:bodyPr>
+          <a:lstStyle/>
+          <a:p>
+            <a:pPr algn="ctr"/>
+            <a:r>
+              <a:rPr sz="900">
+                <a:solidFill>
+                  <a:srgbClr val="EF6B45"/>
+                </a:solidFill>
+                <a:latin typeface="Menlo"/>
+              </a:rPr>
+              <a:t>FIND US ON LINKEDIN</a:t>
             </a:r>
           </a:p>
         </p:txBody>

</xml_diff>